<commit_message>
Complete locked HHAR confirmation and clarify manuscript notation, references and reproduction
</commit_message>
<xml_diff>
--- a/figures/Fig1_editable.pptx
+++ b/figures/Fig1_editable.pptx
@@ -2,13 +2,13 @@
 <file path=ppt/presentation.xml><?xml version="1.0" encoding="utf-8"?>
 <p:presentation xmlns:p="http://schemas.openxmlformats.org/presentationml/2006/main">
   <p:sldMasterIdLst>
-    <p:sldMasterId xmlns:r="http://schemas.openxmlformats.org/officeDocument/2006/relationships" id="2147483648" r:id="Rb1ba89dc92014c1c"/>
+    <p:sldMasterId xmlns:r="http://schemas.openxmlformats.org/officeDocument/2006/relationships" id="2147483648" r:id="Rde71189d5bb64ff0"/>
   </p:sldMasterIdLst>
   <p:notesMasterIdLst>
-    <p:notesMasterId xmlns:r="http://schemas.openxmlformats.org/officeDocument/2006/relationships" r:id="Re5dae93136bf40e9"/>
+    <p:notesMasterId xmlns:r="http://schemas.openxmlformats.org/officeDocument/2006/relationships" r:id="R5170eac8c06b41e8"/>
   </p:notesMasterIdLst>
   <p:sldIdLst>
-    <p:sldId xmlns:r="http://schemas.openxmlformats.org/officeDocument/2006/relationships" id="256" r:id="R8da46653a78747ca"/>
+    <p:sldId xmlns:r="http://schemas.openxmlformats.org/officeDocument/2006/relationships" id="256" r:id="Rdb47237d37c14bfe"/>
   </p:sldIdLst>
   <p:sldSz cx="15240000" cy="8953500"/>
   <p:notesSz cx="6858000" cy="9144000"/>
@@ -442,7 +442,7 @@
           <a:lstStyle xmlns:a="http://schemas.openxmlformats.org/drawingml/2006/main"/>
           <a:p xmlns:a="http://schemas.openxmlformats.org/drawingml/2006/main">
             <a:r>
-              <a:t>Overall architecture of horizon-calibrated finite-pool reference-set emulation. Original scientific diagram based on work/revision6/protocol.json, horizon.py and sequential.py. The trained classifier is frozen. Calibration/test participant IDs are disjoint from training and each other. The target batch supplies inputs and all class scores, never true labels, to the stopping rule. Label queries follow a uniform random permutation of a fixed reference pool. Offline DP boundaries depend only on pool size, reference rank, confidence error and declared checkpoints. At census the full reference quantile is known exactly. The guarantee preserves the reference predictor; it does not establish new 90-percent coverage under subject shift. True test labels are used only in subsequent evaluation and are intentionally outside this algorithm diagram. Native PowerPoint text, shapes and connectors are editable.</a:t>
+              <a:t>Overall architecture of horizon-calibrated finite-pool reference-set emulation. Original scientific diagram based on work/revision6/protocol.json, horizon.py and sequential.py. The trained classifier is frozen. Calibration/test participant IDs are disjoint from training and each other. The monitoring batch supplies inputs and all class scores, never true labels, to the stopping rule. Label queries follow a uniform random permutation of a fixed reference pool. Offline DP boundaries depend only on pool size, reference rank, confidence error and declared checkpoints. At census the full reference quantile is known exactly. The guarantee preserves the reference predictor; it does not establish new 90-percent coverage under subject shift. True test labels are used only in subsequent evaluation and are intentionally outside this algorithm diagram. Native PowerPoint text, shapes and connectors are editable.</a:t>
             </a:r>
           </a:p>
         </p:txBody>
@@ -510,7 +510,7 @@
   </p:cSld>
   <p:clrMap bg1="lt1" tx1="dk1" bg2="lt2" tx2="dk2" accent1="accent1" accent2="accent2" accent3="accent3" accent4="accent4" accent5="accent5" accent6="accent6" hlink="hlink" folHlink="folHlink"/>
   <p:sldLayoutIdLst>
-    <p:sldLayoutId xmlns:r="http://schemas.openxmlformats.org/officeDocument/2006/relationships" id="2147483649" r:id="R9bded1783b244540"/>
+    <p:sldLayoutId xmlns:r="http://schemas.openxmlformats.org/officeDocument/2006/relationships" id="2147483649" r:id="Rcc797d7f6b564a15"/>
   </p:sldLayoutIdLst>
   <p:txStyles>
     <p:titleStyle>
@@ -1061,7 +1061,7 @@
           <p:cNvPr id="54" name="Training participants">
             <a:extLst xmlns:a="http://schemas.openxmlformats.org/drawingml/2006/main">
               <a:ext uri="{FF2B5EF4-FFF2-40B4-BE49-F238E27FC236}">
-                <a16:creationId xmlns:a16="http://schemas.microsoft.com/office/drawing/2014/main" id="{4F779956-6D84-4040-836E-07C865F2DB30}"/>
+                <a16:creationId xmlns:a16="http://schemas.microsoft.com/office/drawing/2014/main" id="{99704C6C-DF25-472A-AE19-31ECEBE4BA8C}"/>
               </a:ext>
             </a:extLst>
           </p:cNvPr>
@@ -1145,7 +1145,7 @@
           <p:cNvPr id="2" name="Frozen recognition model">
             <a:extLst xmlns:a="http://schemas.openxmlformats.org/drawingml/2006/main">
               <a:ext uri="{FF2B5EF4-FFF2-40B4-BE49-F238E27FC236}">
-                <a16:creationId xmlns:a16="http://schemas.microsoft.com/office/drawing/2014/main" id="{C528E313-4194-4EC3-967C-FA7B733681F3}"/>
+                <a16:creationId xmlns:a16="http://schemas.microsoft.com/office/drawing/2014/main" id="{16285455-25EB-4AE3-A049-A2BCE8278EC6}"/>
               </a:ext>
             </a:extLst>
           </p:cNvPr>
@@ -1226,10 +1226,10 @@
       </p:sp>
       <p:sp>
         <p:nvSpPr>
-          <p:cNvPr id="3" name="Unlabeled target batch">
+          <p:cNvPr id="3" name="Unlabeled monitoring batch">
             <a:extLst xmlns:a="http://schemas.openxmlformats.org/drawingml/2006/main">
               <a:ext uri="{FF2B5EF4-FFF2-40B4-BE49-F238E27FC236}">
-                <a16:creationId xmlns:a16="http://schemas.microsoft.com/office/drawing/2014/main" id="{5CB537F4-C7BC-4E3C-B91F-CE18CED16A20}"/>
+                <a16:creationId xmlns:a16="http://schemas.microsoft.com/office/drawing/2014/main" id="{CE19BFFB-C511-4CC5-9B84-1CC7B9206881}"/>
               </a:ext>
             </a:extLst>
           </p:cNvPr>
@@ -1280,7 +1280,7 @@
                 <a:ea typeface="Arial"/>
                 <a:cs typeface="Arial"/>
               </a:rPr>
-              <a:t>Target batch: inputs only</a:t>
+              <a:t>Monitoring batch: inputs only</a:t>
             </a:r>
           </a:p>
           <a:p xmlns:a="http://schemas.openxmlformats.org/drawingml/2006/main">
@@ -1365,7 +1365,7 @@
           <p:cNvPr id="6" name="Finite calibration pool">
             <a:extLst xmlns:a="http://schemas.openxmlformats.org/drawingml/2006/main">
               <a:ext uri="{FF2B5EF4-FFF2-40B4-BE49-F238E27FC236}">
-                <a16:creationId xmlns:a16="http://schemas.microsoft.com/office/drawing/2014/main" id="{6B657D0F-828B-4C4D-ACF8-EE7B2C32A674}"/>
+                <a16:creationId xmlns:a16="http://schemas.microsoft.com/office/drawing/2014/main" id="{E6BD9840-B6AA-4C35-9F28-4FC6C68B9ED0}"/>
               </a:ext>
             </a:extLst>
           </p:cNvPr>
@@ -1472,7 +1472,7 @@
           <p:cNvPr id="7" name="Query next labels">
             <a:extLst xmlns:a="http://schemas.openxmlformats.org/drawingml/2006/main">
               <a:ext uri="{FF2B5EF4-FFF2-40B4-BE49-F238E27FC236}">
-                <a16:creationId xmlns:a16="http://schemas.microsoft.com/office/drawing/2014/main" id="{6C2F6EBB-728C-411D-AD09-8A7B1082341E}"/>
+                <a16:creationId xmlns:a16="http://schemas.microsoft.com/office/drawing/2014/main" id="{8DCA9BDA-3213-4F3B-B6CC-44E6E2B9DC63}"/>
               </a:ext>
             </a:extLst>
           </p:cNvPr>
@@ -1579,7 +1579,7 @@
           <p:cNvPr id="8" name="Quantile interval">
             <a:extLst xmlns:a="http://schemas.openxmlformats.org/drawingml/2006/main">
               <a:ext uri="{FF2B5EF4-FFF2-40B4-BE49-F238E27FC236}">
-                <a16:creationId xmlns:a16="http://schemas.microsoft.com/office/drawing/2014/main" id="{139EE879-CA82-4B4E-9A54-61EF74B97091}"/>
+                <a16:creationId xmlns:a16="http://schemas.microsoft.com/office/drawing/2014/main" id="{985C966F-5EBB-472F-A1BD-2FD132AA58DD}"/>
               </a:ext>
             </a:extLst>
           </p:cNvPr>
@@ -1686,7 +1686,7 @@
           <p:cNvPr id="9" name="Return prediction sets">
             <a:extLst xmlns:a="http://schemas.openxmlformats.org/drawingml/2006/main">
               <a:ext uri="{FF2B5EF4-FFF2-40B4-BE49-F238E27FC236}">
-                <a16:creationId xmlns:a16="http://schemas.microsoft.com/office/drawing/2014/main" id="{DB0E1D32-03FB-4910-9EEC-191B05D9F064}"/>
+                <a16:creationId xmlns:a16="http://schemas.microsoft.com/office/drawing/2014/main" id="{44CC0F45-520E-4EA6-9AE6-0D06FC08751B}"/>
               </a:ext>
             </a:extLst>
           </p:cNvPr>
@@ -1822,7 +1822,7 @@
           <p:cNvPr id="12" name="Connector anchor 1">
             <a:extLst xmlns:a="http://schemas.openxmlformats.org/drawingml/2006/main">
               <a:ext uri="{FF2B5EF4-FFF2-40B4-BE49-F238E27FC236}">
-                <a16:creationId xmlns:a16="http://schemas.microsoft.com/office/drawing/2014/main" id="{6DD706D0-A5E5-435C-82C0-F2689F61FA9C}"/>
+                <a16:creationId xmlns:a16="http://schemas.microsoft.com/office/drawing/2014/main" id="{CE89CD97-89E0-4E32-BAB9-D1F0531B6185}"/>
               </a:ext>
             </a:extLst>
           </p:cNvPr>
@@ -1850,7 +1850,7 @@
           <p:cNvPr id="13" name="Connector anchor 2">
             <a:extLst xmlns:a="http://schemas.openxmlformats.org/drawingml/2006/main">
               <a:ext uri="{FF2B5EF4-FFF2-40B4-BE49-F238E27FC236}">
-                <a16:creationId xmlns:a16="http://schemas.microsoft.com/office/drawing/2014/main" id="{BDC051AD-0CC4-49E2-8C3C-3644EEF41343}"/>
+                <a16:creationId xmlns:a16="http://schemas.microsoft.com/office/drawing/2014/main" id="{9D2A9210-44ED-4A0A-9F21-6D7E404DE1F3}"/>
               </a:ext>
             </a:extLst>
           </p:cNvPr>
@@ -1956,7 +1956,7 @@
           <p:cNvPr id="17" name="Offline boundary calibration">
             <a:extLst xmlns:a="http://schemas.openxmlformats.org/drawingml/2006/main">
               <a:ext uri="{FF2B5EF4-FFF2-40B4-BE49-F238E27FC236}">
-                <a16:creationId xmlns:a16="http://schemas.microsoft.com/office/drawing/2014/main" id="{C04206F5-1E96-40D6-8E62-289BDD0C73D1}"/>
+                <a16:creationId xmlns:a16="http://schemas.microsoft.com/office/drawing/2014/main" id="{53DDDB2F-54D9-4BF0-B548-5312E90C3650}"/>
               </a:ext>
             </a:extLst>
           </p:cNvPr>
@@ -2063,7 +2063,7 @@
           <p:cNvPr id="18" name="Label-free stopping decision">
             <a:extLst xmlns:a="http://schemas.openxmlformats.org/drawingml/2006/main">
               <a:ext uri="{FF2B5EF4-FFF2-40B4-BE49-F238E27FC236}">
-                <a16:creationId xmlns:a16="http://schemas.microsoft.com/office/drawing/2014/main" id="{C6250BC1-58A9-4D70-8126-8388BD6863C6}"/>
+                <a16:creationId xmlns:a16="http://schemas.microsoft.com/office/drawing/2014/main" id="{62C8397E-CF68-4F62-92C6-7B4364C5E633}"/>
               </a:ext>
             </a:extLst>
           </p:cNvPr>
@@ -2114,7 +2114,7 @@
                 <a:ea typeface="Arial"/>
                 <a:cs typeface="Arial"/>
               </a:rPr>
-              <a:t>Set changes on the unlabeled target batch</a:t>
+              <a:t>Set changes on the unlabeled monitoring batch</a:t>
             </a:r>
           </a:p>
           <a:p xmlns:a="http://schemas.openxmlformats.org/drawingml/2006/main">
@@ -2196,7 +2196,7 @@
           <p:cNvPr id="20" name="Connector anchor 3">
             <a:extLst xmlns:a="http://schemas.openxmlformats.org/drawingml/2006/main">
               <a:ext uri="{FF2B5EF4-FFF2-40B4-BE49-F238E27FC236}">
-                <a16:creationId xmlns:a16="http://schemas.microsoft.com/office/drawing/2014/main" id="{97BDC78D-7AC4-41EA-AC65-3AAF9EEE1765}"/>
+                <a16:creationId xmlns:a16="http://schemas.microsoft.com/office/drawing/2014/main" id="{2D8F9C3D-A818-4161-BB4B-830A5E461E0F}"/>
               </a:ext>
             </a:extLst>
           </p:cNvPr>
@@ -2224,7 +2224,7 @@
           <p:cNvPr id="21" name="Connector anchor 4">
             <a:extLst xmlns:a="http://schemas.openxmlformats.org/drawingml/2006/main">
               <a:ext uri="{FF2B5EF4-FFF2-40B4-BE49-F238E27FC236}">
-                <a16:creationId xmlns:a16="http://schemas.microsoft.com/office/drawing/2014/main" id="{AAD4574D-2CE1-458A-953D-E49C25E40220}"/>
+                <a16:creationId xmlns:a16="http://schemas.microsoft.com/office/drawing/2014/main" id="{F0CDC7C6-E641-4ED1-B8B4-C9292C3900D2}"/>
               </a:ext>
             </a:extLst>
           </p:cNvPr>
@@ -2252,7 +2252,7 @@
           <p:cNvPr id="22" name="Connector anchor 5">
             <a:extLst xmlns:a="http://schemas.openxmlformats.org/drawingml/2006/main">
               <a:ext uri="{FF2B5EF4-FFF2-40B4-BE49-F238E27FC236}">
-                <a16:creationId xmlns:a16="http://schemas.microsoft.com/office/drawing/2014/main" id="{7982D765-09D8-462C-984D-F7C230EDF7D9}"/>
+                <a16:creationId xmlns:a16="http://schemas.microsoft.com/office/drawing/2014/main" id="{202A524B-A641-4FA6-AE8E-2395DB7D8763}"/>
               </a:ext>
             </a:extLst>
           </p:cNvPr>
@@ -2410,7 +2410,7 @@
           <p:cNvPr id="28" name="Connector anchor 6">
             <a:extLst xmlns:a="http://schemas.openxmlformats.org/drawingml/2006/main">
               <a:ext uri="{FF2B5EF4-FFF2-40B4-BE49-F238E27FC236}">
-                <a16:creationId xmlns:a16="http://schemas.microsoft.com/office/drawing/2014/main" id="{132C45C5-30FE-41A2-B39B-6907C224C30A}"/>
+                <a16:creationId xmlns:a16="http://schemas.microsoft.com/office/drawing/2014/main" id="{F415F92A-86B0-4AB0-8687-A5CAA978B0D3}"/>
               </a:ext>
             </a:extLst>
           </p:cNvPr>
@@ -2438,7 +2438,7 @@
           <p:cNvPr id="29" name="Connector anchor 7">
             <a:extLst xmlns:a="http://schemas.openxmlformats.org/drawingml/2006/main">
               <a:ext uri="{FF2B5EF4-FFF2-40B4-BE49-F238E27FC236}">
-                <a16:creationId xmlns:a16="http://schemas.microsoft.com/office/drawing/2014/main" id="{BE1A791C-54D4-4A92-837C-43262DF3C31F}"/>
+                <a16:creationId xmlns:a16="http://schemas.microsoft.com/office/drawing/2014/main" id="{E87CBE6D-99F6-44C3-BE06-B6467F0C2EA2}"/>
               </a:ext>
             </a:extLst>
           </p:cNvPr>
@@ -2466,7 +2466,7 @@
           <p:cNvPr id="30" name="Connector anchor 8">
             <a:extLst xmlns:a="http://schemas.openxmlformats.org/drawingml/2006/main">
               <a:ext uri="{FF2B5EF4-FFF2-40B4-BE49-F238E27FC236}">
-                <a16:creationId xmlns:a16="http://schemas.microsoft.com/office/drawing/2014/main" id="{24F2824E-06A4-430A-ACB0-088A3ABE410D}"/>
+                <a16:creationId xmlns:a16="http://schemas.microsoft.com/office/drawing/2014/main" id="{414A6E96-8DEA-4E7C-A304-E6D78F517AB7}"/>
               </a:ext>
             </a:extLst>
           </p:cNvPr>
@@ -2598,7 +2598,7 @@
           <p:cNvPr id="35" name="Connector anchor 9">
             <a:extLst xmlns:a="http://schemas.openxmlformats.org/drawingml/2006/main">
               <a:ext uri="{FF2B5EF4-FFF2-40B4-BE49-F238E27FC236}">
-                <a16:creationId xmlns:a16="http://schemas.microsoft.com/office/drawing/2014/main" id="{B81B6F54-89C8-4796-8D1F-CA6E7E2ABC86}"/>
+                <a16:creationId xmlns:a16="http://schemas.microsoft.com/office/drawing/2014/main" id="{E6740BC5-91B9-4AE5-B714-236201281EEA}"/>
               </a:ext>
             </a:extLst>
           </p:cNvPr>
@@ -2626,7 +2626,7 @@
           <p:cNvPr id="36" name="Connector anchor 10">
             <a:extLst xmlns:a="http://schemas.openxmlformats.org/drawingml/2006/main">
               <a:ext uri="{FF2B5EF4-FFF2-40B4-BE49-F238E27FC236}">
-                <a16:creationId xmlns:a16="http://schemas.microsoft.com/office/drawing/2014/main" id="{CFDAB64B-BF88-4F4C-8D80-2068970FF23F}"/>
+                <a16:creationId xmlns:a16="http://schemas.microsoft.com/office/drawing/2014/main" id="{D4D09160-43FC-4A89-B492-8FAAE7BC7E16}"/>
               </a:ext>
             </a:extLst>
           </p:cNvPr>
@@ -2654,7 +2654,7 @@
           <p:cNvPr id="37" name="Connector anchor 11">
             <a:extLst xmlns:a="http://schemas.openxmlformats.org/drawingml/2006/main">
               <a:ext uri="{FF2B5EF4-FFF2-40B4-BE49-F238E27FC236}">
-                <a16:creationId xmlns:a16="http://schemas.microsoft.com/office/drawing/2014/main" id="{669831F8-2ADF-4489-9B19-6373E9450828}"/>
+                <a16:creationId xmlns:a16="http://schemas.microsoft.com/office/drawing/2014/main" id="{7F39B724-BB41-49E6-A99C-D2C1C7DE304F}"/>
               </a:ext>
             </a:extLst>
           </p:cNvPr>
@@ -2786,7 +2786,7 @@
           <p:cNvPr id="42" name="Stop decision label">
             <a:extLst xmlns:a="http://schemas.openxmlformats.org/drawingml/2006/main">
               <a:ext uri="{FF2B5EF4-FFF2-40B4-BE49-F238E27FC236}">
-                <a16:creationId xmlns:a16="http://schemas.microsoft.com/office/drawing/2014/main" id="{C5C060C1-E7DB-4CB0-94C3-198B6CB2EB04}"/>
+                <a16:creationId xmlns:a16="http://schemas.microsoft.com/office/drawing/2014/main" id="{D233DB7F-3342-4BEF-AAFD-D0ECFAD66E0F}"/>
               </a:ext>
             </a:extLst>
           </p:cNvPr>
@@ -2843,7 +2843,7 @@
           <p:cNvPr id="43" name="Connector anchor 12">
             <a:extLst xmlns:a="http://schemas.openxmlformats.org/drawingml/2006/main">
               <a:ext uri="{FF2B5EF4-FFF2-40B4-BE49-F238E27FC236}">
-                <a16:creationId xmlns:a16="http://schemas.microsoft.com/office/drawing/2014/main" id="{166ED08C-D4C0-455A-B165-4AEC18564896}"/>
+                <a16:creationId xmlns:a16="http://schemas.microsoft.com/office/drawing/2014/main" id="{8EF65A61-9096-495A-80DB-F468A5ADFD07}"/>
               </a:ext>
             </a:extLst>
           </p:cNvPr>
@@ -2871,7 +2871,7 @@
           <p:cNvPr id="44" name="Connector anchor 13">
             <a:extLst xmlns:a="http://schemas.openxmlformats.org/drawingml/2006/main">
               <a:ext uri="{FF2B5EF4-FFF2-40B4-BE49-F238E27FC236}">
-                <a16:creationId xmlns:a16="http://schemas.microsoft.com/office/drawing/2014/main" id="{31C245AC-72BF-461A-B2D8-27819A2EBCFE}"/>
+                <a16:creationId xmlns:a16="http://schemas.microsoft.com/office/drawing/2014/main" id="{A0D40698-E1D8-4043-8683-E8F13907243B}"/>
               </a:ext>
             </a:extLst>
           </p:cNvPr>
@@ -2899,7 +2899,7 @@
           <p:cNvPr id="45" name="Connector anchor 14">
             <a:extLst xmlns:a="http://schemas.openxmlformats.org/drawingml/2006/main">
               <a:ext uri="{FF2B5EF4-FFF2-40B4-BE49-F238E27FC236}">
-                <a16:creationId xmlns:a16="http://schemas.microsoft.com/office/drawing/2014/main" id="{51180D70-CEE5-4A82-96FE-1901751D3121}"/>
+                <a16:creationId xmlns:a16="http://schemas.microsoft.com/office/drawing/2014/main" id="{5F0A597D-5AB2-4215-93EE-C78D08DFB6AE}"/>
               </a:ext>
             </a:extLst>
           </p:cNvPr>
@@ -2927,7 +2927,7 @@
           <p:cNvPr id="46" name="Connector anchor 15">
             <a:extLst xmlns:a="http://schemas.openxmlformats.org/drawingml/2006/main">
               <a:ext uri="{FF2B5EF4-FFF2-40B4-BE49-F238E27FC236}">
-                <a16:creationId xmlns:a16="http://schemas.microsoft.com/office/drawing/2014/main" id="{68E9E1F3-DB76-477C-8383-2B84243761BD}"/>
+                <a16:creationId xmlns:a16="http://schemas.microsoft.com/office/drawing/2014/main" id="{72E7B67D-068B-4752-8207-6AF19BC6754C}"/>
               </a:ext>
             </a:extLst>
           </p:cNvPr>
@@ -3085,7 +3085,7 @@
           <p:cNvPr id="52" name="Continue decision label">
             <a:extLst xmlns:a="http://schemas.openxmlformats.org/drawingml/2006/main">
               <a:ext uri="{FF2B5EF4-FFF2-40B4-BE49-F238E27FC236}">
-                <a16:creationId xmlns:a16="http://schemas.microsoft.com/office/drawing/2014/main" id="{A52EFED3-3A02-4D76-9801-49499DEEE3FF}"/>
+                <a16:creationId xmlns:a16="http://schemas.microsoft.com/office/drawing/2014/main" id="{D8ED6585-F313-4987-B4C8-261E52A30C49}"/>
               </a:ext>
             </a:extLst>
           </p:cNvPr>
@@ -3142,7 +3142,7 @@
           <p:cNvPr id="53" name="Guarantee scope">
             <a:extLst xmlns:a="http://schemas.openxmlformats.org/drawingml/2006/main">
               <a:ext uri="{FF2B5EF4-FFF2-40B4-BE49-F238E27FC236}">
-                <a16:creationId xmlns:a16="http://schemas.microsoft.com/office/drawing/2014/main" id="{B08A9028-5448-490D-AB24-C71231C1276F}"/>
+                <a16:creationId xmlns:a16="http://schemas.microsoft.com/office/drawing/2014/main" id="{D82B94CE-02D4-4628-AB36-6B30605973CF}"/>
               </a:ext>
             </a:extLst>
           </p:cNvPr>
@@ -3212,7 +3212,7 @@
                 <a:ea typeface="Arial"/>
                 <a:cs typeface="Arial"/>
               </a:rPr>
-              <a:t>C(x; qref) ⊆ C(x; Uₜ) for every x; mean extra labels ≤ τ on the target batch</a:t>
+              <a:t>C(x; qref) ⊆ C(x; Uₜ) for every x; mean extra labels ≤ τ on the monitoring batch</a:t>
             </a:r>
           </a:p>
         </p:txBody>
@@ -3220,7 +3220,7 @@
     </p:spTree>
     <p:extLst>
       <p:ext uri="{BB962C8B-B14F-4D97-AF65-F5344CB8AC3E}">
-        <p14:creationId xmlns:p14="http://schemas.microsoft.com/office/powerpoint/2010/main" val="712769499"/>
+        <p14:creationId xmlns:p14="http://schemas.microsoft.com/office/powerpoint/2010/main" val="1564202642"/>
       </p:ext>
     </p:extLst>
   </p:cSld>

</xml_diff>

<commit_message>
Refine journal figures and deliver checked PAA LaTeX source under the JRC repository name
</commit_message>
<xml_diff>
--- a/figures/Fig1_editable.pptx
+++ b/figures/Fig1_editable.pptx
@@ -2,13 +2,13 @@
 <file path=ppt/presentation.xml><?xml version="1.0" encoding="utf-8"?>
 <p:presentation xmlns:p="http://schemas.openxmlformats.org/presentationml/2006/main">
   <p:sldMasterIdLst>
-    <p:sldMasterId xmlns:r="http://schemas.openxmlformats.org/officeDocument/2006/relationships" id="2147483648" r:id="Rde71189d5bb64ff0"/>
+    <p:sldMasterId xmlns:r="http://schemas.openxmlformats.org/officeDocument/2006/relationships" id="2147483648" r:id="R3711ee2778ce4633"/>
   </p:sldMasterIdLst>
   <p:notesMasterIdLst>
-    <p:notesMasterId xmlns:r="http://schemas.openxmlformats.org/officeDocument/2006/relationships" r:id="R5170eac8c06b41e8"/>
+    <p:notesMasterId xmlns:r="http://schemas.openxmlformats.org/officeDocument/2006/relationships" r:id="R5015220a2b304e5d"/>
   </p:notesMasterIdLst>
   <p:sldIdLst>
-    <p:sldId xmlns:r="http://schemas.openxmlformats.org/officeDocument/2006/relationships" id="256" r:id="Rdb47237d37c14bfe"/>
+    <p:sldId xmlns:r="http://schemas.openxmlformats.org/officeDocument/2006/relationships" id="256" r:id="Rf87e30dfcc644cb7"/>
   </p:sldIdLst>
   <p:sldSz cx="15240000" cy="8953500"/>
   <p:notesSz cx="6858000" cy="9144000"/>
@@ -442,7 +442,7 @@
           <a:lstStyle xmlns:a="http://schemas.openxmlformats.org/drawingml/2006/main"/>
           <a:p xmlns:a="http://schemas.openxmlformats.org/drawingml/2006/main">
             <a:r>
-              <a:t>Overall architecture of horizon-calibrated finite-pool reference-set emulation. Original scientific diagram based on work/revision6/protocol.json, horizon.py and sequential.py. The trained classifier is frozen. Calibration/test participant IDs are disjoint from training and each other. The monitoring batch supplies inputs and all class scores, never true labels, to the stopping rule. Label queries follow a uniform random permutation of a fixed reference pool. Offline DP boundaries depend only on pool size, reference rank, confidence error and declared checkpoints. At census the full reference quantile is known exactly. The guarantee preserves the reference predictor; it does not establish new 90-percent coverage under subject shift. True test labels are used only in subsequent evaluation and are intentionally outside this algorithm diagram. Native PowerPoint text, shapes and connectors are editable.</a:t>
+              <a:t>Overall architecture of horizon-calibrated finite-pool reference-set emulation. Original scientific diagram based on work/revision6/protocol.json, horizon.py and sequential.py. The trained classifier is frozen. L and U in this diagram denote the running lower and upper bounds; D_t is the stopping statistic in manuscript Eq.9. Calibration/test participant IDs are disjoint from training and each other. The monitoring batch supplies inputs and all class scores, never true labels, to the stopping rule. Label queries follow a uniform random permutation of a fixed reference pool. Offline DP boundaries depend only on pool size, reference rank, confidence error and declared checkpoints. At census the full reference quantile is known exactly. The guarantee preserves the reference predictor; it does not establish new 90-percent coverage under subject shift. True test labels are used only in subsequent evaluation and are intentionally outside this algorithm diagram. Native PowerPoint text, shapes and connectors are editable.</a:t>
             </a:r>
           </a:p>
         </p:txBody>
@@ -510,7 +510,7 @@
   </p:cSld>
   <p:clrMap bg1="lt1" tx1="dk1" bg2="lt2" tx2="dk2" accent1="accent1" accent2="accent2" accent3="accent3" accent4="accent4" accent5="accent5" accent6="accent6" hlink="hlink" folHlink="folHlink"/>
   <p:sldLayoutIdLst>
-    <p:sldLayoutId xmlns:r="http://schemas.openxmlformats.org/officeDocument/2006/relationships" id="2147483649" r:id="Rcc797d7f6b564a15"/>
+    <p:sldLayoutId xmlns:r="http://schemas.openxmlformats.org/officeDocument/2006/relationships" id="2147483649" r:id="R011947bfee304680"/>
   </p:sldLayoutIdLst>
   <p:txStyles>
     <p:titleStyle>
@@ -1058,10 +1058,10 @@
       </p:grpSpPr>
       <p:sp>
         <p:nvSpPr>
-          <p:cNvPr id="54" name="Training participants">
+          <p:cNvPr id="57" name="Training participants">
             <a:extLst xmlns:a="http://schemas.openxmlformats.org/drawingml/2006/main">
               <a:ext uri="{FF2B5EF4-FFF2-40B4-BE49-F238E27FC236}">
-                <a16:creationId xmlns:a16="http://schemas.microsoft.com/office/drawing/2014/main" id="{99704C6C-DF25-472A-AE19-31ECEBE4BA8C}"/>
+                <a16:creationId xmlns:a16="http://schemas.microsoft.com/office/drawing/2014/main" id="{AA3A485E-1A52-4072-8769-FB7DE28471F5}"/>
               </a:ext>
             </a:extLst>
           </p:cNvPr>
@@ -1145,7 +1145,7 @@
           <p:cNvPr id="2" name="Frozen recognition model">
             <a:extLst xmlns:a="http://schemas.openxmlformats.org/drawingml/2006/main">
               <a:ext uri="{FF2B5EF4-FFF2-40B4-BE49-F238E27FC236}">
-                <a16:creationId xmlns:a16="http://schemas.microsoft.com/office/drawing/2014/main" id="{16285455-25EB-4AE3-A049-A2BCE8278EC6}"/>
+                <a16:creationId xmlns:a16="http://schemas.microsoft.com/office/drawing/2014/main" id="{86F48E3E-5AFE-4ECF-83E7-F37B9A9A7092}"/>
               </a:ext>
             </a:extLst>
           </p:cNvPr>
@@ -1229,7 +1229,7 @@
           <p:cNvPr id="3" name="Unlabeled monitoring batch">
             <a:extLst xmlns:a="http://schemas.openxmlformats.org/drawingml/2006/main">
               <a:ext uri="{FF2B5EF4-FFF2-40B4-BE49-F238E27FC236}">
-                <a16:creationId xmlns:a16="http://schemas.microsoft.com/office/drawing/2014/main" id="{CE19BFFB-C511-4CC5-9B84-1CC7B9206881}"/>
+                <a16:creationId xmlns:a16="http://schemas.microsoft.com/office/drawing/2014/main" id="{AABF0A70-B277-4236-9A7C-7256B720F5CB}"/>
               </a:ext>
             </a:extLst>
           </p:cNvPr>
@@ -1310,7 +1310,7 @@
       </p:sp>
       <p:cxnSp>
         <p:nvCxnSpPr>
-          <p:cNvPr id="57" name=""/>
+          <p:cNvPr id="60" name=""/>
           <p:cNvCxnSpPr>
             <a:stCxn xmlns:a="http://schemas.openxmlformats.org/drawingml/2006/main" id="1" idx="3"/>
             <a:endCxn xmlns:a="http://schemas.openxmlformats.org/drawingml/2006/main" id="2" idx="1"/>
@@ -1336,7 +1336,7 @@
       </p:cxnSp>
       <p:cxnSp>
         <p:nvCxnSpPr>
-          <p:cNvPr id="58" name=""/>
+          <p:cNvPr id="61" name=""/>
           <p:cNvCxnSpPr>
             <a:stCxn xmlns:a="http://schemas.openxmlformats.org/drawingml/2006/main" id="2" idx="3"/>
             <a:endCxn xmlns:a="http://schemas.openxmlformats.org/drawingml/2006/main" id="3" idx="1"/>
@@ -1365,7 +1365,7 @@
           <p:cNvPr id="6" name="Finite calibration pool">
             <a:extLst xmlns:a="http://schemas.openxmlformats.org/drawingml/2006/main">
               <a:ext uri="{FF2B5EF4-FFF2-40B4-BE49-F238E27FC236}">
-                <a16:creationId xmlns:a16="http://schemas.microsoft.com/office/drawing/2014/main" id="{E6BD9840-B6AA-4C35-9F28-4FC6C68B9ED0}"/>
+                <a16:creationId xmlns:a16="http://schemas.microsoft.com/office/drawing/2014/main" id="{25EC6ADB-8C44-4F02-8AB0-95947A5ED49C}"/>
               </a:ext>
             </a:extLst>
           </p:cNvPr>
@@ -1472,7 +1472,7 @@
           <p:cNvPr id="7" name="Query next labels">
             <a:extLst xmlns:a="http://schemas.openxmlformats.org/drawingml/2006/main">
               <a:ext uri="{FF2B5EF4-FFF2-40B4-BE49-F238E27FC236}">
-                <a16:creationId xmlns:a16="http://schemas.microsoft.com/office/drawing/2014/main" id="{8DCA9BDA-3213-4F3B-B6CC-44E6E2B9DC63}"/>
+                <a16:creationId xmlns:a16="http://schemas.microsoft.com/office/drawing/2014/main" id="{8B67F42D-9E42-4FC0-815C-64ACF36A3182}"/>
               </a:ext>
             </a:extLst>
           </p:cNvPr>
@@ -1579,7 +1579,7 @@
           <p:cNvPr id="8" name="Quantile interval">
             <a:extLst xmlns:a="http://schemas.openxmlformats.org/drawingml/2006/main">
               <a:ext uri="{FF2B5EF4-FFF2-40B4-BE49-F238E27FC236}">
-                <a16:creationId xmlns:a16="http://schemas.microsoft.com/office/drawing/2014/main" id="{985C966F-5EBB-472F-A1BD-2FD132AA58DD}"/>
+                <a16:creationId xmlns:a16="http://schemas.microsoft.com/office/drawing/2014/main" id="{CA412845-2E88-4D85-8E7E-C8B48A201323}"/>
               </a:ext>
             </a:extLst>
           </p:cNvPr>
@@ -1630,7 +1630,7 @@
                 <a:ea typeface="Arial"/>
                 <a:cs typeface="Arial"/>
               </a:rPr>
-              <a:t>Quantile bracket</a:t>
+              <a:t>Update quantile bracket</a:t>
             </a:r>
           </a:p>
           <a:p xmlns:a="http://schemas.openxmlformats.org/drawingml/2006/main">
@@ -1653,7 +1653,7 @@
                 <a:ea typeface="Arial"/>
                 <a:cs typeface="Arial"/>
               </a:rPr>
-              <a:t>[Lₜ, Uₜ]</a:t>
+              <a:t>Running intersection</a:t>
             </a:r>
           </a:p>
           <a:p xmlns:a="http://schemas.openxmlformats.org/drawingml/2006/main">
@@ -1676,7 +1676,7 @@
                 <a:ea typeface="Arial"/>
                 <a:cs typeface="Arial"/>
               </a:rPr>
-              <a:t>Running intersection</a:t>
+              <a:t>Bounds L and U</a:t>
             </a:r>
           </a:p>
         </p:txBody>
@@ -1686,7 +1686,7 @@
           <p:cNvPr id="9" name="Return prediction sets">
             <a:extLst xmlns:a="http://schemas.openxmlformats.org/drawingml/2006/main">
               <a:ext uri="{FF2B5EF4-FFF2-40B4-BE49-F238E27FC236}">
-                <a16:creationId xmlns:a16="http://schemas.microsoft.com/office/drawing/2014/main" id="{44CC0F45-520E-4EA6-9AE6-0D06FC08751B}"/>
+                <a16:creationId xmlns:a16="http://schemas.microsoft.com/office/drawing/2014/main" id="{6D560A88-BB0E-4D80-AECA-CAF4EE8BE302}"/>
               </a:ext>
             </a:extLst>
           </p:cNvPr>
@@ -1737,7 +1737,7 @@
                 <a:ea typeface="Arial"/>
                 <a:cs typeface="Arial"/>
               </a:rPr>
-              <a:t>Return C(x; Uₜ)</a:t>
+              <a:t>Return C(x; U)</a:t>
             </a:r>
           </a:p>
           <a:p xmlns:a="http://schemas.openxmlformats.org/drawingml/2006/main">
@@ -1760,14 +1760,14 @@
                 <a:ea typeface="Arial"/>
                 <a:cs typeface="Arial"/>
               </a:rPr>
-              <a:t>Stop querying labels</a:t>
+              <a:t>Stop label queries</a:t>
             </a:r>
           </a:p>
         </p:txBody>
       </p:sp>
       <p:cxnSp>
         <p:nvCxnSpPr>
-          <p:cNvPr id="63" name=""/>
+          <p:cNvPr id="66" name=""/>
           <p:cNvCxnSpPr>
             <a:stCxn xmlns:a="http://schemas.openxmlformats.org/drawingml/2006/main" id="6" idx="3"/>
             <a:endCxn xmlns:a="http://schemas.openxmlformats.org/drawingml/2006/main" id="7" idx="1"/>
@@ -1793,7 +1793,7 @@
       </p:cxnSp>
       <p:cxnSp>
         <p:nvCxnSpPr>
-          <p:cNvPr id="64" name=""/>
+          <p:cNvPr id="67" name=""/>
           <p:cNvCxnSpPr>
             <a:stCxn xmlns:a="http://schemas.openxmlformats.org/drawingml/2006/main" id="7" idx="3"/>
             <a:endCxn xmlns:a="http://schemas.openxmlformats.org/drawingml/2006/main" id="8" idx="1"/>
@@ -1822,7 +1822,7 @@
           <p:cNvPr id="12" name="Connector anchor 1">
             <a:extLst xmlns:a="http://schemas.openxmlformats.org/drawingml/2006/main">
               <a:ext uri="{FF2B5EF4-FFF2-40B4-BE49-F238E27FC236}">
-                <a16:creationId xmlns:a16="http://schemas.microsoft.com/office/drawing/2014/main" id="{CE89CD97-89E0-4E32-BAB9-D1F0531B6185}"/>
+                <a16:creationId xmlns:a16="http://schemas.microsoft.com/office/drawing/2014/main" id="{DAF92535-8139-47D2-8C59-272B3D362B6A}"/>
               </a:ext>
             </a:extLst>
           </p:cNvPr>
@@ -1850,7 +1850,7 @@
           <p:cNvPr id="13" name="Connector anchor 2">
             <a:extLst xmlns:a="http://schemas.openxmlformats.org/drawingml/2006/main">
               <a:ext uri="{FF2B5EF4-FFF2-40B4-BE49-F238E27FC236}">
-                <a16:creationId xmlns:a16="http://schemas.microsoft.com/office/drawing/2014/main" id="{9D2A9210-44ED-4A0A-9F21-6D7E404DE1F3}"/>
+                <a16:creationId xmlns:a16="http://schemas.microsoft.com/office/drawing/2014/main" id="{5E9F143D-7E5D-4E90-90E2-F89AB73B48FB}"/>
               </a:ext>
             </a:extLst>
           </p:cNvPr>
@@ -1875,7 +1875,7 @@
       </p:sp>
       <p:cxnSp>
         <p:nvCxnSpPr>
-          <p:cNvPr id="67" name=""/>
+          <p:cNvPr id="70" name=""/>
           <p:cNvCxnSpPr>
             <a:stCxn xmlns:a="http://schemas.openxmlformats.org/drawingml/2006/main" id="2" idx="2"/>
             <a:endCxn xmlns:a="http://schemas.openxmlformats.org/drawingml/2006/main" id="12" idx="0"/>
@@ -1901,7 +1901,7 @@
       </p:cxnSp>
       <p:cxnSp>
         <p:nvCxnSpPr>
-          <p:cNvPr id="68" name=""/>
+          <p:cNvPr id="71" name=""/>
           <p:cNvCxnSpPr>
             <a:stCxn xmlns:a="http://schemas.openxmlformats.org/drawingml/2006/main" id="12" idx="1"/>
             <a:endCxn xmlns:a="http://schemas.openxmlformats.org/drawingml/2006/main" id="13" idx="3"/>
@@ -1927,7 +1927,7 @@
       </p:cxnSp>
       <p:cxnSp>
         <p:nvCxnSpPr>
-          <p:cNvPr id="69" name=""/>
+          <p:cNvPr id="72" name=""/>
           <p:cNvCxnSpPr>
             <a:stCxn xmlns:a="http://schemas.openxmlformats.org/drawingml/2006/main" id="13" idx="2"/>
             <a:endCxn xmlns:a="http://schemas.openxmlformats.org/drawingml/2006/main" id="6" idx="0"/>
@@ -1956,7 +1956,7 @@
           <p:cNvPr id="17" name="Offline boundary calibration">
             <a:extLst xmlns:a="http://schemas.openxmlformats.org/drawingml/2006/main">
               <a:ext uri="{FF2B5EF4-FFF2-40B4-BE49-F238E27FC236}">
-                <a16:creationId xmlns:a16="http://schemas.microsoft.com/office/drawing/2014/main" id="{53DDDB2F-54D9-4BF0-B548-5312E90C3650}"/>
+                <a16:creationId xmlns:a16="http://schemas.microsoft.com/office/drawing/2014/main" id="{4B1BD93C-43E1-46ED-9CB3-06C4037E72F7}"/>
               </a:ext>
             </a:extLst>
           </p:cNvPr>
@@ -2063,7 +2063,7 @@
           <p:cNvPr id="18" name="Label-free stopping decision">
             <a:extLst xmlns:a="http://schemas.openxmlformats.org/drawingml/2006/main">
               <a:ext uri="{FF2B5EF4-FFF2-40B4-BE49-F238E27FC236}">
-                <a16:creationId xmlns:a16="http://schemas.microsoft.com/office/drawing/2014/main" id="{62C8397E-CF68-4F62-92C6-7B4364C5E633}"/>
+                <a16:creationId xmlns:a16="http://schemas.microsoft.com/office/drawing/2014/main" id="{FA2D7B31-7FC8-460D-89E3-6CC4FBEFC754}"/>
               </a:ext>
             </a:extLst>
           </p:cNvPr>
@@ -2114,7 +2114,7 @@
                 <a:ea typeface="Arial"/>
                 <a:cs typeface="Arial"/>
               </a:rPr>
-              <a:t>Set changes on the unlabeled monitoring batch</a:t>
+              <a:t>Compare sets on monitoring inputs</a:t>
             </a:r>
           </a:p>
           <a:p xmlns:a="http://schemas.openxmlformats.org/drawingml/2006/main">
@@ -2137,7 +2137,7 @@
                 <a:ea typeface="Arial"/>
                 <a:cs typeface="Arial"/>
               </a:rPr>
-              <a:t>Δₜ = meanₓ ( |C(x; Uₜ)| − |C(x; Lₜ)| )</a:t>
+              <a:t>Dₜ = meanₓ ( |C(x; U)| − |C(x; L)| )</a:t>
             </a:r>
           </a:p>
           <a:p xmlns:a="http://schemas.openxmlformats.org/drawingml/2006/main">
@@ -2160,14 +2160,14 @@
                 <a:ea typeface="Arial"/>
                 <a:cs typeface="Arial"/>
               </a:rPr>
-              <a:t>Stop if Δₜ ≤ τ; otherwise query again</a:t>
+              <a:t>Stop if Dₜ ≤ τ; otherwise query again</a:t>
             </a:r>
           </a:p>
         </p:txBody>
       </p:sp>
       <p:cxnSp>
         <p:nvCxnSpPr>
-          <p:cNvPr id="72" name=""/>
+          <p:cNvPr id="75" name=""/>
           <p:cNvCxnSpPr>
             <a:stCxn xmlns:a="http://schemas.openxmlformats.org/drawingml/2006/main" id="6" idx="2"/>
             <a:endCxn xmlns:a="http://schemas.openxmlformats.org/drawingml/2006/main" id="17" idx="0"/>
@@ -2196,7 +2196,7 @@
           <p:cNvPr id="20" name="Connector anchor 3">
             <a:extLst xmlns:a="http://schemas.openxmlformats.org/drawingml/2006/main">
               <a:ext uri="{FF2B5EF4-FFF2-40B4-BE49-F238E27FC236}">
-                <a16:creationId xmlns:a16="http://schemas.microsoft.com/office/drawing/2014/main" id="{2D8F9C3D-A818-4161-BB4B-830A5E461E0F}"/>
+                <a16:creationId xmlns:a16="http://schemas.microsoft.com/office/drawing/2014/main" id="{261EC351-8176-4AB3-A8DB-D6E141A4D9A9}"/>
               </a:ext>
             </a:extLst>
           </p:cNvPr>
@@ -2224,7 +2224,7 @@
           <p:cNvPr id="21" name="Connector anchor 4">
             <a:extLst xmlns:a="http://schemas.openxmlformats.org/drawingml/2006/main">
               <a:ext uri="{FF2B5EF4-FFF2-40B4-BE49-F238E27FC236}">
-                <a16:creationId xmlns:a16="http://schemas.microsoft.com/office/drawing/2014/main" id="{F0CDC7C6-E641-4ED1-B8B4-C9292C3900D2}"/>
+                <a16:creationId xmlns:a16="http://schemas.microsoft.com/office/drawing/2014/main" id="{ECC64DC1-024E-473C-8A4E-7DA3786AAECC}"/>
               </a:ext>
             </a:extLst>
           </p:cNvPr>
@@ -2252,7 +2252,7 @@
           <p:cNvPr id="22" name="Connector anchor 5">
             <a:extLst xmlns:a="http://schemas.openxmlformats.org/drawingml/2006/main">
               <a:ext uri="{FF2B5EF4-FFF2-40B4-BE49-F238E27FC236}">
-                <a16:creationId xmlns:a16="http://schemas.microsoft.com/office/drawing/2014/main" id="{202A524B-A641-4FA6-AE8E-2395DB7D8763}"/>
+                <a16:creationId xmlns:a16="http://schemas.microsoft.com/office/drawing/2014/main" id="{C0438843-8FF7-41CC-8338-2D0E0CB60E35}"/>
               </a:ext>
             </a:extLst>
           </p:cNvPr>
@@ -2277,7 +2277,7 @@
       </p:sp>
       <p:cxnSp>
         <p:nvCxnSpPr>
-          <p:cNvPr id="76" name=""/>
+          <p:cNvPr id="79" name=""/>
           <p:cNvCxnSpPr>
             <a:stCxn xmlns:a="http://schemas.openxmlformats.org/drawingml/2006/main" id="17" idx="3"/>
             <a:endCxn xmlns:a="http://schemas.openxmlformats.org/drawingml/2006/main" id="20" idx="1"/>
@@ -2303,7 +2303,7 @@
       </p:cxnSp>
       <p:cxnSp>
         <p:nvCxnSpPr>
-          <p:cNvPr id="77" name=""/>
+          <p:cNvPr id="80" name=""/>
           <p:cNvCxnSpPr>
             <a:stCxn xmlns:a="http://schemas.openxmlformats.org/drawingml/2006/main" id="20" idx="0"/>
             <a:endCxn xmlns:a="http://schemas.openxmlformats.org/drawingml/2006/main" id="21" idx="2"/>
@@ -2329,7 +2329,7 @@
       </p:cxnSp>
       <p:cxnSp>
         <p:nvCxnSpPr>
-          <p:cNvPr id="78" name=""/>
+          <p:cNvPr id="81" name=""/>
           <p:cNvCxnSpPr>
             <a:stCxn xmlns:a="http://schemas.openxmlformats.org/drawingml/2006/main" id="21" idx="3"/>
             <a:endCxn xmlns:a="http://schemas.openxmlformats.org/drawingml/2006/main" id="22" idx="1"/>
@@ -2355,7 +2355,7 @@
       </p:cxnSp>
       <p:cxnSp>
         <p:nvCxnSpPr>
-          <p:cNvPr id="79" name=""/>
+          <p:cNvPr id="82" name=""/>
           <p:cNvCxnSpPr>
             <a:stCxn xmlns:a="http://schemas.openxmlformats.org/drawingml/2006/main" id="22" idx="2"/>
             <a:endCxn xmlns:a="http://schemas.openxmlformats.org/drawingml/2006/main" id="8" idx="0"/>
@@ -2381,7 +2381,7 @@
       </p:cxnSp>
       <p:cxnSp>
         <p:nvCxnSpPr>
-          <p:cNvPr id="80" name=""/>
+          <p:cNvPr id="83" name=""/>
           <p:cNvCxnSpPr>
             <a:stCxn xmlns:a="http://schemas.openxmlformats.org/drawingml/2006/main" id="8" idx="2"/>
             <a:endCxn xmlns:a="http://schemas.openxmlformats.org/drawingml/2006/main" id="18" idx="0"/>
@@ -2410,7 +2410,7 @@
           <p:cNvPr id="28" name="Connector anchor 6">
             <a:extLst xmlns:a="http://schemas.openxmlformats.org/drawingml/2006/main">
               <a:ext uri="{FF2B5EF4-FFF2-40B4-BE49-F238E27FC236}">
-                <a16:creationId xmlns:a16="http://schemas.microsoft.com/office/drawing/2014/main" id="{F415F92A-86B0-4AB0-8687-A5CAA978B0D3}"/>
+                <a16:creationId xmlns:a16="http://schemas.microsoft.com/office/drawing/2014/main" id="{D8500474-9166-4EAC-9D12-7CA6D6CBDA7F}"/>
               </a:ext>
             </a:extLst>
           </p:cNvPr>
@@ -2438,7 +2438,7 @@
           <p:cNvPr id="29" name="Connector anchor 7">
             <a:extLst xmlns:a="http://schemas.openxmlformats.org/drawingml/2006/main">
               <a:ext uri="{FF2B5EF4-FFF2-40B4-BE49-F238E27FC236}">
-                <a16:creationId xmlns:a16="http://schemas.microsoft.com/office/drawing/2014/main" id="{E87CBE6D-99F6-44C3-BE06-B6467F0C2EA2}"/>
+                <a16:creationId xmlns:a16="http://schemas.microsoft.com/office/drawing/2014/main" id="{2C051A12-D812-448A-A909-8801CF69C60F}"/>
               </a:ext>
             </a:extLst>
           </p:cNvPr>
@@ -2466,7 +2466,7 @@
           <p:cNvPr id="30" name="Connector anchor 8">
             <a:extLst xmlns:a="http://schemas.openxmlformats.org/drawingml/2006/main">
               <a:ext uri="{FF2B5EF4-FFF2-40B4-BE49-F238E27FC236}">
-                <a16:creationId xmlns:a16="http://schemas.microsoft.com/office/drawing/2014/main" id="{414A6E96-8DEA-4E7C-A304-E6D78F517AB7}"/>
+                <a16:creationId xmlns:a16="http://schemas.microsoft.com/office/drawing/2014/main" id="{2897371D-0EF7-4347-91DE-E3A2C7B1DA15}"/>
               </a:ext>
             </a:extLst>
           </p:cNvPr>
@@ -2491,7 +2491,7 @@
       </p:sp>
       <p:cxnSp>
         <p:nvCxnSpPr>
-          <p:cNvPr id="84" name=""/>
+          <p:cNvPr id="87" name=""/>
           <p:cNvCxnSpPr>
             <a:stCxn xmlns:a="http://schemas.openxmlformats.org/drawingml/2006/main" id="3" idx="3"/>
             <a:endCxn xmlns:a="http://schemas.openxmlformats.org/drawingml/2006/main" id="28" idx="1"/>
@@ -2517,7 +2517,7 @@
       </p:cxnSp>
       <p:cxnSp>
         <p:nvCxnSpPr>
-          <p:cNvPr id="85" name=""/>
+          <p:cNvPr id="88" name=""/>
           <p:cNvCxnSpPr>
             <a:stCxn xmlns:a="http://schemas.openxmlformats.org/drawingml/2006/main" id="28" idx="2"/>
             <a:endCxn xmlns:a="http://schemas.openxmlformats.org/drawingml/2006/main" id="29" idx="0"/>
@@ -2543,7 +2543,7 @@
       </p:cxnSp>
       <p:cxnSp>
         <p:nvCxnSpPr>
-          <p:cNvPr id="86" name=""/>
+          <p:cNvPr id="89" name=""/>
           <p:cNvCxnSpPr>
             <a:stCxn xmlns:a="http://schemas.openxmlformats.org/drawingml/2006/main" id="29" idx="1"/>
             <a:endCxn xmlns:a="http://schemas.openxmlformats.org/drawingml/2006/main" id="30" idx="3"/>
@@ -2569,7 +2569,7 @@
       </p:cxnSp>
       <p:cxnSp>
         <p:nvCxnSpPr>
-          <p:cNvPr id="87" name=""/>
+          <p:cNvPr id="90" name=""/>
           <p:cNvCxnSpPr>
             <a:stCxn xmlns:a="http://schemas.openxmlformats.org/drawingml/2006/main" id="30" idx="2"/>
             <a:endCxn xmlns:a="http://schemas.openxmlformats.org/drawingml/2006/main" id="18" idx="0"/>
@@ -2598,7 +2598,7 @@
           <p:cNvPr id="35" name="Connector anchor 9">
             <a:extLst xmlns:a="http://schemas.openxmlformats.org/drawingml/2006/main">
               <a:ext uri="{FF2B5EF4-FFF2-40B4-BE49-F238E27FC236}">
-                <a16:creationId xmlns:a16="http://schemas.microsoft.com/office/drawing/2014/main" id="{E6740BC5-91B9-4AE5-B714-236201281EEA}"/>
+                <a16:creationId xmlns:a16="http://schemas.microsoft.com/office/drawing/2014/main" id="{BFFFA54A-152F-4B3E-878C-BED515C15FDE}"/>
               </a:ext>
             </a:extLst>
           </p:cNvPr>
@@ -2626,7 +2626,7 @@
           <p:cNvPr id="36" name="Connector anchor 10">
             <a:extLst xmlns:a="http://schemas.openxmlformats.org/drawingml/2006/main">
               <a:ext uri="{FF2B5EF4-FFF2-40B4-BE49-F238E27FC236}">
-                <a16:creationId xmlns:a16="http://schemas.microsoft.com/office/drawing/2014/main" id="{D4D09160-43FC-4A89-B492-8FAAE7BC7E16}"/>
+                <a16:creationId xmlns:a16="http://schemas.microsoft.com/office/drawing/2014/main" id="{93656090-1FFD-40ED-9285-7266A2E93A4D}"/>
               </a:ext>
             </a:extLst>
           </p:cNvPr>
@@ -2654,7 +2654,7 @@
           <p:cNvPr id="37" name="Connector anchor 11">
             <a:extLst xmlns:a="http://schemas.openxmlformats.org/drawingml/2006/main">
               <a:ext uri="{FF2B5EF4-FFF2-40B4-BE49-F238E27FC236}">
-                <a16:creationId xmlns:a16="http://schemas.microsoft.com/office/drawing/2014/main" id="{7F39B724-BB41-49E6-A99C-D2C1C7DE304F}"/>
+                <a16:creationId xmlns:a16="http://schemas.microsoft.com/office/drawing/2014/main" id="{3109A756-BF14-4FA6-95B3-7523306D4C4B}"/>
               </a:ext>
             </a:extLst>
           </p:cNvPr>
@@ -2679,7 +2679,7 @@
       </p:sp>
       <p:cxnSp>
         <p:nvCxnSpPr>
-          <p:cNvPr id="91" name=""/>
+          <p:cNvPr id="94" name=""/>
           <p:cNvCxnSpPr>
             <a:stCxn xmlns:a="http://schemas.openxmlformats.org/drawingml/2006/main" id="18" idx="3"/>
             <a:endCxn xmlns:a="http://schemas.openxmlformats.org/drawingml/2006/main" id="35" idx="1"/>
@@ -2705,7 +2705,7 @@
       </p:cxnSp>
       <p:cxnSp>
         <p:nvCxnSpPr>
-          <p:cNvPr id="92" name=""/>
+          <p:cNvPr id="95" name=""/>
           <p:cNvCxnSpPr>
             <a:stCxn xmlns:a="http://schemas.openxmlformats.org/drawingml/2006/main" id="35" idx="0"/>
             <a:endCxn xmlns:a="http://schemas.openxmlformats.org/drawingml/2006/main" id="36" idx="2"/>
@@ -2731,7 +2731,7 @@
       </p:cxnSp>
       <p:cxnSp>
         <p:nvCxnSpPr>
-          <p:cNvPr id="93" name=""/>
+          <p:cNvPr id="96" name=""/>
           <p:cNvCxnSpPr>
             <a:stCxn xmlns:a="http://schemas.openxmlformats.org/drawingml/2006/main" id="36" idx="1"/>
             <a:endCxn xmlns:a="http://schemas.openxmlformats.org/drawingml/2006/main" id="37" idx="3"/>
@@ -2757,7 +2757,7 @@
       </p:cxnSp>
       <p:cxnSp>
         <p:nvCxnSpPr>
-          <p:cNvPr id="94" name=""/>
+          <p:cNvPr id="97" name=""/>
           <p:cNvCxnSpPr>
             <a:stCxn xmlns:a="http://schemas.openxmlformats.org/drawingml/2006/main" id="37" idx="0"/>
             <a:endCxn xmlns:a="http://schemas.openxmlformats.org/drawingml/2006/main" id="9" idx="2"/>
@@ -2786,7 +2786,7 @@
           <p:cNvPr id="42" name="Stop decision label">
             <a:extLst xmlns:a="http://schemas.openxmlformats.org/drawingml/2006/main">
               <a:ext uri="{FF2B5EF4-FFF2-40B4-BE49-F238E27FC236}">
-                <a16:creationId xmlns:a16="http://schemas.microsoft.com/office/drawing/2014/main" id="{D233DB7F-3342-4BEF-AAFD-D0ECFAD66E0F}"/>
+                <a16:creationId xmlns:a16="http://schemas.microsoft.com/office/drawing/2014/main" id="{BC9644D2-3401-4772-93AB-4A3EA73E4C5E}"/>
               </a:ext>
             </a:extLst>
           </p:cNvPr>
@@ -2843,7 +2843,7 @@
           <p:cNvPr id="43" name="Connector anchor 12">
             <a:extLst xmlns:a="http://schemas.openxmlformats.org/drawingml/2006/main">
               <a:ext uri="{FF2B5EF4-FFF2-40B4-BE49-F238E27FC236}">
-                <a16:creationId xmlns:a16="http://schemas.microsoft.com/office/drawing/2014/main" id="{8EF65A61-9096-495A-80DB-F468A5ADFD07}"/>
+                <a16:creationId xmlns:a16="http://schemas.microsoft.com/office/drawing/2014/main" id="{2E1D1C17-3923-4106-9D58-BF5D8324D89C}"/>
               </a:ext>
             </a:extLst>
           </p:cNvPr>
@@ -2871,7 +2871,7 @@
           <p:cNvPr id="44" name="Connector anchor 13">
             <a:extLst xmlns:a="http://schemas.openxmlformats.org/drawingml/2006/main">
               <a:ext uri="{FF2B5EF4-FFF2-40B4-BE49-F238E27FC236}">
-                <a16:creationId xmlns:a16="http://schemas.microsoft.com/office/drawing/2014/main" id="{A0D40698-E1D8-4043-8683-E8F13907243B}"/>
+                <a16:creationId xmlns:a16="http://schemas.microsoft.com/office/drawing/2014/main" id="{1255FD16-0D97-4C58-BB1A-9C4D064096A7}"/>
               </a:ext>
             </a:extLst>
           </p:cNvPr>
@@ -2899,7 +2899,7 @@
           <p:cNvPr id="45" name="Connector anchor 14">
             <a:extLst xmlns:a="http://schemas.openxmlformats.org/drawingml/2006/main">
               <a:ext uri="{FF2B5EF4-FFF2-40B4-BE49-F238E27FC236}">
-                <a16:creationId xmlns:a16="http://schemas.microsoft.com/office/drawing/2014/main" id="{5F0A597D-5AB2-4215-93EE-C78D08DFB6AE}"/>
+                <a16:creationId xmlns:a16="http://schemas.microsoft.com/office/drawing/2014/main" id="{AF1F5F0F-DE83-4824-AAD7-0396616F386E}"/>
               </a:ext>
             </a:extLst>
           </p:cNvPr>
@@ -2927,7 +2927,7 @@
           <p:cNvPr id="46" name="Connector anchor 15">
             <a:extLst xmlns:a="http://schemas.openxmlformats.org/drawingml/2006/main">
               <a:ext uri="{FF2B5EF4-FFF2-40B4-BE49-F238E27FC236}">
-                <a16:creationId xmlns:a16="http://schemas.microsoft.com/office/drawing/2014/main" id="{72E7B67D-068B-4752-8207-6AF19BC6754C}"/>
+                <a16:creationId xmlns:a16="http://schemas.microsoft.com/office/drawing/2014/main" id="{5A06B52F-726B-4278-8AA1-5CD979BE3F3A}"/>
               </a:ext>
             </a:extLst>
           </p:cNvPr>
@@ -2952,7 +2952,7 @@
       </p:sp>
       <p:cxnSp>
         <p:nvCxnSpPr>
-          <p:cNvPr id="100" name=""/>
+          <p:cNvPr id="103" name=""/>
           <p:cNvCxnSpPr>
             <a:stCxn xmlns:a="http://schemas.openxmlformats.org/drawingml/2006/main" id="18" idx="2"/>
             <a:endCxn xmlns:a="http://schemas.openxmlformats.org/drawingml/2006/main" id="43" idx="0"/>
@@ -2978,7 +2978,7 @@
       </p:cxnSp>
       <p:cxnSp>
         <p:nvCxnSpPr>
-          <p:cNvPr id="101" name=""/>
+          <p:cNvPr id="104" name=""/>
           <p:cNvCxnSpPr>
             <a:stCxn xmlns:a="http://schemas.openxmlformats.org/drawingml/2006/main" id="43" idx="1"/>
             <a:endCxn xmlns:a="http://schemas.openxmlformats.org/drawingml/2006/main" id="44" idx="3"/>
@@ -3004,7 +3004,7 @@
       </p:cxnSp>
       <p:cxnSp>
         <p:nvCxnSpPr>
-          <p:cNvPr id="102" name=""/>
+          <p:cNvPr id="105" name=""/>
           <p:cNvCxnSpPr>
             <a:stCxn xmlns:a="http://schemas.openxmlformats.org/drawingml/2006/main" id="44" idx="0"/>
             <a:endCxn xmlns:a="http://schemas.openxmlformats.org/drawingml/2006/main" id="45" idx="2"/>
@@ -3030,7 +3030,7 @@
       </p:cxnSp>
       <p:cxnSp>
         <p:nvCxnSpPr>
-          <p:cNvPr id="103" name=""/>
+          <p:cNvPr id="106" name=""/>
           <p:cNvCxnSpPr>
             <a:stCxn xmlns:a="http://schemas.openxmlformats.org/drawingml/2006/main" id="45" idx="1"/>
             <a:endCxn xmlns:a="http://schemas.openxmlformats.org/drawingml/2006/main" id="46" idx="3"/>
@@ -3056,7 +3056,7 @@
       </p:cxnSp>
       <p:cxnSp>
         <p:nvCxnSpPr>
-          <p:cNvPr id="104" name=""/>
+          <p:cNvPr id="107" name=""/>
           <p:cNvCxnSpPr>
             <a:stCxn xmlns:a="http://schemas.openxmlformats.org/drawingml/2006/main" id="46" idx="0"/>
             <a:endCxn xmlns:a="http://schemas.openxmlformats.org/drawingml/2006/main" id="7" idx="2"/>
@@ -3085,7 +3085,7 @@
           <p:cNvPr id="52" name="Continue decision label">
             <a:extLst xmlns:a="http://schemas.openxmlformats.org/drawingml/2006/main">
               <a:ext uri="{FF2B5EF4-FFF2-40B4-BE49-F238E27FC236}">
-                <a16:creationId xmlns:a16="http://schemas.microsoft.com/office/drawing/2014/main" id="{D8ED6585-F313-4987-B4C8-261E52A30C49}"/>
+                <a16:creationId xmlns:a16="http://schemas.microsoft.com/office/drawing/2014/main" id="{F537196C-E4A0-4905-ADD7-D68491EC33AD}"/>
               </a:ext>
             </a:extLst>
           </p:cNvPr>
@@ -3142,7 +3142,7 @@
           <p:cNvPr id="53" name="Guarantee scope">
             <a:extLst xmlns:a="http://schemas.openxmlformats.org/drawingml/2006/main">
               <a:ext uri="{FF2B5EF4-FFF2-40B4-BE49-F238E27FC236}">
-                <a16:creationId xmlns:a16="http://schemas.microsoft.com/office/drawing/2014/main" id="{D82B94CE-02D4-4628-AB36-6B30605973CF}"/>
+                <a16:creationId xmlns:a16="http://schemas.microsoft.com/office/drawing/2014/main" id="{47CDB1AD-F8B7-4430-B621-00D1DAF8D903}"/>
               </a:ext>
             </a:extLst>
           </p:cNvPr>
@@ -3212,15 +3212,186 @@
                 <a:ea typeface="Arial"/>
                 <a:cs typeface="Arial"/>
               </a:rPr>
-              <a:t>C(x; qref) ⊆ C(x; Uₜ) for every x; mean extra labels ≤ τ on the monitoring batch</a:t>
+              <a:t>C(x; qref) ⊆ C(x; U) for every x; mean extra labels ≤ τ on the monitoring batch</a:t>
             </a:r>
           </a:p>
         </p:txBody>
       </p:sp>
+      <p:sp>
+        <p:nvSpPr>
+          <p:cNvPr id="54" name="Inputs panel">
+            <a:extLst xmlns:a="http://schemas.openxmlformats.org/drawingml/2006/main">
+              <a:ext uri="{FF2B5EF4-FFF2-40B4-BE49-F238E27FC236}">
+                <a16:creationId xmlns:a16="http://schemas.microsoft.com/office/drawing/2014/main" id="{3C24F72E-482C-4375-B0D8-ADC0BD801A69}"/>
+              </a:ext>
+            </a:extLst>
+          </p:cNvPr>
+          <p:cNvSpPr>
+            <a:spLocks xmlns:a="http://schemas.openxmlformats.org/drawingml/2006/main" noGrp="1"/>
+          </p:cNvSpPr>
+          <p:nvPr/>
+        </p:nvSpPr>
+        <p:spPr>
+          <a:xfrm xmlns:a="http://schemas.openxmlformats.org/drawingml/2006/main">
+            <a:off x="381000" y="0"/>
+            <a:ext cx="6953250" cy="285750"/>
+          </a:xfrm>
+          <a:prstGeom xmlns:a="http://schemas.openxmlformats.org/drawingml/2006/main" prst="rect">
+            <a:avLst/>
+          </a:prstGeom>
+          <a:noFill xmlns:a="http://schemas.openxmlformats.org/drawingml/2006/main"/>
+          <a:ln xmlns:a="http://schemas.openxmlformats.org/drawingml/2006/main" w="0">
+            <a:noFill/>
+          </a:ln>
+        </p:spPr>
+        <p:txBody>
+          <a:bodyPr xmlns:a="http://schemas.openxmlformats.org/drawingml/2006/main" lIns="19050" tIns="19050" rIns="19050" bIns="19050" anchor="ctr">
+            <a:noAutofit/>
+          </a:bodyPr>
+          <a:lstStyle xmlns:a="http://schemas.openxmlformats.org/drawingml/2006/main"/>
+          <a:p xmlns:a="http://schemas.openxmlformats.org/drawingml/2006/main">
+            <a:pPr algn="ctr">
+              <a:defRPr sz="2100">
+                <a:solidFill>
+                  <a:srgbClr val="1B2D3B"/>
+                </a:solidFill>
+                <a:latin typeface="Arial"/>
+                <a:ea typeface="Arial"/>
+                <a:cs typeface="Arial"/>
+              </a:defRPr>
+            </a:pPr>
+            <a:r>
+              <a:rPr sz="2100">
+                <a:solidFill>
+                  <a:srgbClr val="1B2D3B"/>
+                </a:solidFill>
+                <a:latin typeface="Arial"/>
+                <a:ea typeface="Arial"/>
+                <a:cs typeface="Arial"/>
+              </a:rPr>
+              <a:t>(a) Fixed model and inputs</a:t>
+            </a:r>
+          </a:p>
+        </p:txBody>
+      </p:sp>
+      <p:sp>
+        <p:nvSpPr>
+          <p:cNvPr id="55" name="Boundary panel">
+            <a:extLst xmlns:a="http://schemas.openxmlformats.org/drawingml/2006/main">
+              <a:ext uri="{FF2B5EF4-FFF2-40B4-BE49-F238E27FC236}">
+                <a16:creationId xmlns:a16="http://schemas.microsoft.com/office/drawing/2014/main" id="{FF716C46-C87A-4D93-A8BE-F28CFA6DDB4C}"/>
+              </a:ext>
+            </a:extLst>
+          </p:cNvPr>
+          <p:cNvSpPr>
+            <a:spLocks xmlns:a="http://schemas.openxmlformats.org/drawingml/2006/main" noGrp="1"/>
+          </p:cNvSpPr>
+          <p:nvPr/>
+        </p:nvSpPr>
+        <p:spPr>
+          <a:xfrm xmlns:a="http://schemas.openxmlformats.org/drawingml/2006/main">
+            <a:off x="381000" y="5095875"/>
+            <a:ext cx="2857500" cy="304800"/>
+          </a:xfrm>
+          <a:prstGeom xmlns:a="http://schemas.openxmlformats.org/drawingml/2006/main" prst="rect">
+            <a:avLst/>
+          </a:prstGeom>
+          <a:noFill xmlns:a="http://schemas.openxmlformats.org/drawingml/2006/main"/>
+          <a:ln xmlns:a="http://schemas.openxmlformats.org/drawingml/2006/main" w="0">
+            <a:noFill/>
+          </a:ln>
+        </p:spPr>
+        <p:txBody>
+          <a:bodyPr xmlns:a="http://schemas.openxmlformats.org/drawingml/2006/main" lIns="19050" tIns="19050" rIns="19050" bIns="19050" anchor="ctr">
+            <a:noAutofit/>
+          </a:bodyPr>
+          <a:lstStyle xmlns:a="http://schemas.openxmlformats.org/drawingml/2006/main"/>
+          <a:p xmlns:a="http://schemas.openxmlformats.org/drawingml/2006/main">
+            <a:pPr algn="ctr">
+              <a:defRPr sz="2100">
+                <a:solidFill>
+                  <a:srgbClr val="1B2D3B"/>
+                </a:solidFill>
+                <a:latin typeface="Arial"/>
+                <a:ea typeface="Arial"/>
+                <a:cs typeface="Arial"/>
+              </a:defRPr>
+            </a:pPr>
+            <a:r>
+              <a:rPr sz="2100">
+                <a:solidFill>
+                  <a:srgbClr val="1B2D3B"/>
+                </a:solidFill>
+                <a:latin typeface="Arial"/>
+                <a:ea typeface="Arial"/>
+                <a:cs typeface="Arial"/>
+              </a:rPr>
+              <a:t>(b) Rank calibration</a:t>
+            </a:r>
+          </a:p>
+        </p:txBody>
+      </p:sp>
+      <p:sp>
+        <p:nvSpPr>
+          <p:cNvPr id="56" name="Query panel">
+            <a:extLst xmlns:a="http://schemas.openxmlformats.org/drawingml/2006/main">
+              <a:ext uri="{FF2B5EF4-FFF2-40B4-BE49-F238E27FC236}">
+                <a16:creationId xmlns:a16="http://schemas.microsoft.com/office/drawing/2014/main" id="{7B32B97C-D31B-49AC-9755-703A0F556AC2}"/>
+              </a:ext>
+            </a:extLst>
+          </p:cNvPr>
+          <p:cNvSpPr>
+            <a:spLocks xmlns:a="http://schemas.openxmlformats.org/drawingml/2006/main" noGrp="1"/>
+          </p:cNvSpPr>
+          <p:nvPr/>
+        </p:nvSpPr>
+        <p:spPr>
+          <a:xfrm xmlns:a="http://schemas.openxmlformats.org/drawingml/2006/main">
+            <a:off x="4476750" y="2286000"/>
+            <a:ext cx="3143250" cy="304800"/>
+          </a:xfrm>
+          <a:prstGeom xmlns:a="http://schemas.openxmlformats.org/drawingml/2006/main" prst="rect">
+            <a:avLst/>
+          </a:prstGeom>
+          <a:noFill xmlns:a="http://schemas.openxmlformats.org/drawingml/2006/main"/>
+          <a:ln xmlns:a="http://schemas.openxmlformats.org/drawingml/2006/main" w="0">
+            <a:noFill/>
+          </a:ln>
+        </p:spPr>
+        <p:txBody>
+          <a:bodyPr xmlns:a="http://schemas.openxmlformats.org/drawingml/2006/main" lIns="19050" tIns="19050" rIns="19050" bIns="19050" anchor="ctr">
+            <a:noAutofit/>
+          </a:bodyPr>
+          <a:lstStyle xmlns:a="http://schemas.openxmlformats.org/drawingml/2006/main"/>
+          <a:p xmlns:a="http://schemas.openxmlformats.org/drawingml/2006/main">
+            <a:pPr algn="ctr">
+              <a:defRPr sz="2100">
+                <a:solidFill>
+                  <a:srgbClr val="1B2D3B"/>
+                </a:solidFill>
+                <a:latin typeface="Arial"/>
+                <a:ea typeface="Arial"/>
+                <a:cs typeface="Arial"/>
+              </a:defRPr>
+            </a:pPr>
+            <a:r>
+              <a:rPr sz="2100">
+                <a:solidFill>
+                  <a:srgbClr val="1B2D3B"/>
+                </a:solidFill>
+                <a:latin typeface="Arial"/>
+                <a:ea typeface="Arial"/>
+                <a:cs typeface="Arial"/>
+              </a:rPr>
+              <a:t>(c) Query and stop</a:t>
+            </a:r>
+          </a:p>
+        </p:txBody>
+      </p:sp>
     </p:spTree>
     <p:extLst>
       <p:ext uri="{BB962C8B-B14F-4D97-AF65-F5344CB8AC3E}">
-        <p14:creationId xmlns:p14="http://schemas.microsoft.com/office/powerpoint/2010/main" val="1564202642"/>
+        <p14:creationId xmlns:p14="http://schemas.microsoft.com/office/powerpoint/2010/main" val="1021556959"/>
       </p:ext>
     </p:extLst>
   </p:cSld>

</xml_diff>